<commit_message>
atelier repush after update
</commit_message>
<xml_diff>
--- a/atelier/atelier-b03-logo-lockups.pptx
+++ b/atelier/atelier-b03-logo-lockups.pptx
@@ -4969,8 +4969,8 @@
         </p:nvSpPr>
         <p:spPr>
           <a:xfrm>
-            <a:off x="7055644" y="6260455"/>
-            <a:ext cx="1939052" cy="447675"/>
+            <a:off x="7055644" y="6269980"/>
+            <a:ext cx="1939052" cy="350490"/>
           </a:xfrm>
           <a:prstGeom prst="rect">
             <a:avLst/>
@@ -4981,7 +4981,11 @@
           <a:bodyPr wrap="none" anchor="t" lIns="0" rIns="0" tIns="0" bIns="0"/>
           <a:lstStyle/>
           <a:p>
-            <a:pPr algn="l"/>
+            <a:pPr algn="l">
+              <a:lnSpc>
+                <a:spcPct val="92000"/>
+              </a:lnSpc>
+            </a:pPr>
             <a:r>
               <a:rPr sz="3000" i="1" b="0">
                 <a:solidFill>
@@ -5004,7 +5008,7 @@
         </p:nvSpPr>
         <p:spPr>
           <a:xfrm>
-            <a:off x="8124676" y="6308080"/>
+            <a:off x="8124676" y="6260455"/>
             <a:ext cx="2457450" cy="350490"/>
           </a:xfrm>
           <a:prstGeom prst="rect">

</xml_diff>